<commit_message>
docs: refresh screenshots, UML, report and presentation for replay, zoom and PT Sans
</commit_message>
<xml_diff>
--- a/docs/presentation/Презентация_ЛР2_Минязов.pptx
+++ b/docs/presentation/Презентация_ЛР2_Минязов.pptx
@@ -1698,7 +1698,7 @@
           <a:p>
             <a:r>
               <a:rPr lang="en-US" dirty="0"/>
-              <a:t>Живая демонстрация: Старт на малой скорости — видно случайные шаги. Затем «Обучить 500» — появляется зелёный путь и надпись «выучила маршрут». Можно включить стрелки, поставить молнию в редакторе на путь и обучить заново — мышь найдёт новый обход.</a:t>
+              <a:t>Живая демонстрация: Старт на малой скорости — видно случайные шаги. Затем «Обучить 500» — появляется зелёный путь и надпись «выучила маршрут». «Пройти выученный путь» — мышь идёт по зелёной линии без случайностей. Можно включить стрелки, поставить молнию в редакторе на путь и обучить заново — мышь найдёт новый обход.</a:t>
             </a:r>
             <a:endParaRPr lang="en-US" dirty="0"/>
           </a:p>
@@ -2581,8 +2581,8 @@
         </p:blipFill>
         <p:spPr>
           <a:xfrm>
-            <a:off x="7651453" y="1645920"/>
-            <a:ext cx="3259414" cy="4846320"/>
+            <a:off x="7768473" y="1645920"/>
+            <a:ext cx="3025375" cy="4846320"/>
           </a:xfrm>
           <a:prstGeom prst="rect">
             <a:avLst/>
@@ -6343,7 +6343,7 @@
                 <a:ea typeface="Calibri" pitchFamily="34" charset="-122"/>
                 <a:cs typeface="Calibri" pitchFamily="34" charset="-120"/>
               </a:rPr>
-              <a:t>клик по границе — стена; клик в клетку — вода, ток, старт, сыр</a:t>
+              <a:t>клик по границе — стена, в клетку — вода, ток, старт, сыр; большой лабиринт можно приближать</a:t>
             </a:r>
             <a:endParaRPr lang="en-US" sz="1400" dirty="0"/>
           </a:p>
@@ -6889,11 +6889,11 @@
         <p:spPr>
           <a:xfrm>
             <a:off x="548640" y="1737360"/>
-            <a:ext cx="3474720" cy="2377440"/>
+            <a:ext cx="3474720" cy="2697480"/>
           </a:xfrm>
           <a:prstGeom prst="roundRect">
             <a:avLst>
-              <a:gd name="adj" fmla="val 4615"/>
+              <a:gd name="adj" fmla="val 4068"/>
             </a:avLst>
           </a:prstGeom>
           <a:solidFill>
@@ -7057,11 +7057,11 @@
         <p:spPr>
           <a:xfrm>
             <a:off x="4297680" y="1737360"/>
-            <a:ext cx="3474720" cy="2377440"/>
+            <a:ext cx="3474720" cy="2697480"/>
           </a:xfrm>
           <a:prstGeom prst="roundRect">
             <a:avLst>
-              <a:gd name="adj" fmla="val 4615"/>
+              <a:gd name="adj" fmla="val 4068"/>
             </a:avLst>
           </a:prstGeom>
           <a:solidFill>
@@ -7150,7 +7150,7 @@
                 <a:ea typeface="Calibri" pitchFamily="34" charset="-122"/>
                 <a:cs typeface="Calibri" pitchFamily="34" charset="-120"/>
               </a:rPr>
-              <a:t>TrainingController — кнопки, скорость</a:t>
+              <a:t>TrainingController — кнопки, скорость, показ пути</a:t>
             </a:r>
             <a:endParaRPr lang="en-US" sz="1500" dirty="0"/>
           </a:p>
@@ -7190,6 +7190,26 @@
                 <a:ea typeface="Calibri" pitchFamily="34" charset="-122"/>
                 <a:cs typeface="Calibri" pitchFamily="34" charset="-120"/>
               </a:rPr>
+              <a:t>Viewport — масштаб</a:t>
+            </a:r>
+            <a:endParaRPr lang="en-US" sz="1500" dirty="0"/>
+          </a:p>
+          <a:p>
+            <a:pPr indent="0" marL="0">
+              <a:spcAft>
+                <a:spcPts val="600"/>
+              </a:spcAft>
+              <a:buNone/>
+            </a:pPr>
+            <a:r>
+              <a:rPr lang="en-US" sz="1500" dirty="0">
+                <a:solidFill>
+                  <a:srgbClr val="2C2C2A"/>
+                </a:solidFill>
+                <a:latin typeface="Calibri" pitchFamily="34" charset="0"/>
+                <a:ea typeface="Calibri" pitchFamily="34" charset="-122"/>
+                <a:cs typeface="Calibri" pitchFamily="34" charset="-120"/>
+              </a:rPr>
               <a:t>SettingsForm, MazeForm — проверка ввода</a:t>
             </a:r>
             <a:endParaRPr lang="en-US" sz="1500" dirty="0"/>
@@ -7205,11 +7225,11 @@
         <p:spPr>
           <a:xfrm>
             <a:off x="8046720" y="1737360"/>
-            <a:ext cx="3474720" cy="2377440"/>
+            <a:ext cx="3474720" cy="2697480"/>
           </a:xfrm>
           <a:prstGeom prst="roundRect">
             <a:avLst>
-              <a:gd name="adj" fmla="val 4615"/>
+              <a:gd name="adj" fmla="val 4068"/>
             </a:avLst>
           </a:prstGeom>
           <a:solidFill>
@@ -7372,7 +7392,7 @@
         </p:nvSpPr>
         <p:spPr>
           <a:xfrm>
-            <a:off x="548640" y="4480560"/>
+            <a:off x="548640" y="4754880"/>
             <a:ext cx="11064240" cy="1188720"/>
           </a:xfrm>
           <a:prstGeom prst="rect">
@@ -7613,8 +7633,8 @@
         </p:blipFill>
         <p:spPr>
           <a:xfrm>
-            <a:off x="960608" y="1755648"/>
-            <a:ext cx="2650783" cy="1645920"/>
+            <a:off x="1159602" y="1755648"/>
+            <a:ext cx="2252796" cy="1645920"/>
           </a:xfrm>
           <a:prstGeom prst="rect">
             <a:avLst/>
@@ -7973,8 +7993,8 @@
         </p:blipFill>
         <p:spPr>
           <a:xfrm>
-            <a:off x="5348975" y="4224528"/>
-            <a:ext cx="1372131" cy="1645920"/>
+            <a:off x="5085109" y="4224528"/>
+            <a:ext cx="1899862" cy="1645920"/>
           </a:xfrm>
           <a:prstGeom prst="rect">
             <a:avLst/>
@@ -8214,7 +8234,7 @@
                 <a:ea typeface="Calibri" pitchFamily="34" charset="-122"/>
                 <a:cs typeface="Calibri" pitchFamily="34" charset="-120"/>
               </a:rPr>
-              <a:t>Первая попытка и после «Обучить 500»</a:t>
+              <a:t>Первая попытка и показ выученного пути после «Обучить 500»</a:t>
             </a:r>
             <a:endParaRPr lang="en-US" sz="1600" dirty="0"/>
           </a:p>
@@ -8246,7 +8266,7 @@
       </p:pic>
       <p:pic>
         <p:nvPicPr>
-          <p:cNvPr id="5" name="Image 1" descr="/Users/azatminyazov/Workspace/university java/2 work/docs/screenshots/gui_2_trained.png">    </p:cNvPr>
+          <p:cNvPr id="5" name="Image 1" descr="/Users/azatminyazov/Workspace/university java/2 work/docs/screenshots/gui_8_replay.png">    </p:cNvPr>
           <p:cNvPicPr>
             <a:picLocks noChangeAspect="1"/>
           </p:cNvPicPr>
@@ -8301,7 +8321,7 @@
                 <a:ea typeface="Calibri" pitchFamily="34" charset="-122"/>
                 <a:cs typeface="Calibri" pitchFamily="34" charset="-120"/>
               </a:rPr>
-              <a:t>Мышь ничего не знает: бродит, бьётся о стены; за 59 шагов −231</a:t>
+              <a:t>Мышь ничего не знает: бродит, бьётся о стены; за 60 шагов −232</a:t>
             </a:r>
             <a:endParaRPr lang="en-US" sz="1500" dirty="0"/>
           </a:p>
@@ -8340,7 +8360,7 @@
                 <a:ea typeface="Calibri" pitchFamily="34" charset="-122"/>
                 <a:cs typeface="Calibri" pitchFamily="34" charset="-120"/>
               </a:rPr>
-              <a:t>Выучила за 112 попыток: обходит ток, пьёт воду; график растёт</a:t>
+              <a:t>Выучила за 112 попыток; показ пути: 29 шагов, +81, ток обойдён</a:t>
             </a:r>
             <a:endParaRPr lang="en-US" sz="1500" dirty="0"/>
           </a:p>

</xml_diff>